<commit_message>
docs: apresentação ExpoJud em HTML com simulador do fluxo de Mandado de Segurança
Apresentação autônoma (um arquivo, funciona offline) com mapa dos 12 fluxos
do MS e simulador animado do processo percorrendo os diagramas, em 5
cenários. Fonte em apresentacao/expojud-2026/src (python build.py).

Co-Authored-By: Claude Opus 5.5 <noreply@anthropic.com>
Claude-Session: https://claude.ai/code/session_01CtmJGrftpkzr6PAqnjM4o8
</commit_message>
<xml_diff>
--- a/apresentacao/expojud-2026/Lab-Fluxos-ExpoJud-2026.pptx
+++ b/apresentacao/expojud-2026/Lab-Fluxos-ExpoJud-2026.pptx
@@ -117,37 +117,37 @@
   <p:extLst>
     <p:ext uri="{521415D9-36F7-43E2-AB2F-B90AF26B5E84}">
       <p14:sectionLst xmlns:p14="http://schemas.microsoft.com/office/powerpoint/2010/main">
-        <p14:section name="Abertura" id="{fc10c617-c40c-653d-de38-66cb5445c864}">
+        <p14:section name="Abertura" id="{20ff6585-2382-5890-4c4c-de06abcdd53f}">
           <p14:sldIdLst>
             <p14:sldId id="256"/>
             <p14:sldId id="257"/>
           </p14:sldIdLst>
         </p14:section>
-        <p14:section name="A ideia" id="{2b9bfbbb-1105-9667-81ee-38b9f5929fe8}">
+        <p14:section name="A ideia" id="{8a541847-8616-ae17-ae2f-3447c9dffe6f}">
           <p14:sldIdLst>
             <p14:sldId id="258"/>
           </p14:sldIdLst>
         </p14:section>
-        <p14:section name="A construção" id="{51444c61-6696-388e-9b5c-be0481246f85}">
+        <p14:section name="A construção" id="{1dda8144-df71-e2e4-1ad4-188a21056a06}">
           <p14:sldIdLst>
             <p14:sldId id="259"/>
             <p14:sldId id="260"/>
             <p14:sldId id="261"/>
           </p14:sldIdLst>
         </p14:section>
-        <p14:section name="O método" id="{35e9b8f0-5a1b-9536-2f61-6665cdc52d72}">
+        <p14:section name="O método" id="{70d64405-fd39-780b-fe85-6d21bc71c87d}">
           <p14:sldIdLst>
             <p14:sldId id="262"/>
           </p14:sldIdLst>
         </p14:section>
-        <p14:section name="Os fluxos" id="{a51a106b-4179-12ef-f3f2-83b9ea50d653}">
+        <p14:section name="Os fluxos" id="{a2f326b1-eb1f-200c-7aff-e98f382898d4}">
           <p14:sldIdLst>
             <p14:sldId id="263"/>
             <p14:sldId id="264"/>
             <p14:sldId id="265"/>
           </p14:sldIdLst>
         </p14:section>
-        <p14:section name="Encerramento" id="{5a9c72b4-e91e-a0b1-ddf5-8b2a8d53c67d}">
+        <p14:section name="Encerramento" id="{5929a6d2-110c-cd9c-af12-88edd57f827f}">
           <p14:sldIdLst>
             <p14:sldId id="266"/>
           </p14:sldIdLst>
@@ -1002,7 +1002,7 @@
             <a:r>
               <a:rPr lang="en-US" dirty="0"/>
               <a:t>~1 min 30 s. Percorrer a linha do tempo da esquerda para a direita.
-(2) A formação da equipe, com gente de negócio e de tecnologia, permitiu passos maiores. Agradecer a Anderson de Sousa Peres e Erick Gama Touret de Faria (TRF1), que deram o apoio necessário nessa formação.
+(2) A formação da equipe, com gente de negócio e de tecnologia, permitiu passos maiores. Agradecer a Anderson de Sousa Peres e Erick Gama Touret de Faria, servidores do TRF1, instrutores dos treinamentos iniciais de formação do Laboratório.
 (3) Execução Fiscal: primeiro fluxo completo para a JF5.
 (4) Primeiras entregas ao TRF5, sob a coordenação do Tribunal e atendendo às demandas dele.
 (5) Aporte do JCP e treinamento do Samuel (próximo slide).</a:t>
@@ -5060,7 +5060,7 @@
                 <a:ea typeface="Arial" pitchFamily="34" charset="-122"/>
                 <a:cs typeface="Arial" pitchFamily="34" charset="-120"/>
               </a:rPr>
-              <a:t>Equipe mista</a:t>
+              <a:t>Equipe formada</a:t>
             </a:r>
             <a:endParaRPr lang="en-US" sz="1700" dirty="0"/>
           </a:p>
@@ -5096,7 +5096,7 @@
                   <a:schemeClr val="accent5"/>
                 </a:solidFill>
               </a:rPr>
-              <a:t>Área fim + área de tecnologia, com apoio de servidores do TRF1</a:t>
+              <a:t>Área fim + tecnologia, capacitadas por instrutores do TRF1</a:t>
             </a:r>
             <a:endParaRPr lang="en-US" sz="1400" dirty="0"/>
           </a:p>
@@ -7003,7 +7003,7 @@
                   <a:schemeClr val="accent5"/>
                 </a:solidFill>
               </a:rPr>
-              <a:t>Anderson de Sousa Peres e Erick Gama Touret de Faria (TRF1) · Samuel de Aguiar Rodrigues (TRF5) · Programa Justiça Centrada nas Pessoas (PNUD)</a:t>
+              <a:t>Anderson de Sousa Peres e Erick Gama Touret de Faria (TRF1), instrutores dos treinamentos iniciais · Samuel de Aguiar Rodrigues (TRF5) · Programa Justiça Centrada nas Pessoas (PNUD)</a:t>
             </a:r>
             <a:endParaRPr lang="en-US" sz="1400" dirty="0"/>
           </a:p>

</xml_diff>